<commit_message>
feat: enhance PPT templates with modern gradient backgrounds and decorative elements
</commit_message>
<xml_diff>
--- a/config/templates/academic_template.pptx
+++ b/config/templates/academic_template.pptx
@@ -3082,6 +3082,22 @@
 <file path=ppt/slides/slide1.xml><?xml version="1.0" encoding="utf-8"?>
 <p:sld xmlns:a="http://schemas.openxmlformats.org/drawingml/2006/main" xmlns:p="http://schemas.openxmlformats.org/presentationml/2006/main" xmlns:r="http://schemas.openxmlformats.org/officeDocument/2006/relationships">
   <p:cSld>
+    <p:bg>
+      <p:bgPr>
+        <a:gradFill rotWithShape="1">
+          <a:gsLst>
+            <a:gs pos="0">
+              <a:srgbClr val="2C3E50"/>
+            </a:gs>
+            <a:gs pos="100000">
+              <a:srgbClr val="34495E"/>
+            </a:gs>
+          </a:gsLst>
+          <a:lin scaled="0" ang="16200000"/>
+        </a:gradFill>
+        <a:effectLst/>
+      </p:bgPr>
+    </p:bg>
     <p:spTree>
       <p:nvGrpSpPr>
         <p:cNvPr id="1" name=""/>
@@ -3105,9 +3121,9 @@
           <a:lstStyle/>
           <a:p>
             <a:pPr>
-              <a:defRPr sz="4000" b="1">
+              <a:defRPr sz="4800" b="1">
                 <a:solidFill>
-                  <a:srgbClr val="333333"/>
+                  <a:srgbClr val="FFFFFF"/>
                 </a:solidFill>
               </a:defRPr>
             </a:pPr>
@@ -3133,15 +3149,144 @@
           <a:lstStyle/>
           <a:p>
             <a:pPr>
-              <a:defRPr sz="2000">
+              <a:defRPr sz="2400">
                 <a:solidFill>
-                  <a:srgbClr val="666666"/>
+                  <a:srgbClr val="ECF0F1"/>
                 </a:solidFill>
               </a:defRPr>
             </a:pPr>
             <a:r>
-              <a:t>适合学术论文、研究报告</a:t>
-            </a:r>
+              <a:t>Research · Innovation · Excellence</a:t>
+            </a:r>
+          </a:p>
+        </p:txBody>
+      </p:sp>
+      <p:sp>
+        <p:nvSpPr>
+          <p:cNvPr id="4" name="Rectangle 3"/>
+          <p:cNvSpPr/>
+          <p:nvPr/>
+        </p:nvSpPr>
+        <p:spPr>
+          <a:xfrm>
+            <a:off x="0" y="0"/>
+            <a:ext cx="182880" cy="5143500"/>
+          </a:xfrm>
+          <a:prstGeom prst="rect">
+            <a:avLst/>
+          </a:prstGeom>
+          <a:solidFill>
+            <a:srgbClr val="E74C3C"/>
+          </a:solidFill>
+          <a:ln>
+            <a:noFill/>
+          </a:ln>
+        </p:spPr>
+        <p:style>
+          <a:lnRef idx="1">
+            <a:schemeClr val="accent1"/>
+          </a:lnRef>
+          <a:fillRef idx="3">
+            <a:schemeClr val="accent1"/>
+          </a:fillRef>
+          <a:effectRef idx="2">
+            <a:schemeClr val="accent1"/>
+          </a:effectRef>
+          <a:fontRef idx="minor">
+            <a:schemeClr val="lt1"/>
+          </a:fontRef>
+        </p:style>
+        <p:txBody>
+          <a:bodyPr rtlCol="0" anchor="ctr"/>
+          <a:lstStyle/>
+          <a:p>
+            <a:pPr algn="ctr"/>
+          </a:p>
+        </p:txBody>
+      </p:sp>
+      <p:sp>
+        <p:nvSpPr>
+          <p:cNvPr id="5" name="Rectangle 4"/>
+          <p:cNvSpPr/>
+          <p:nvPr/>
+        </p:nvSpPr>
+        <p:spPr>
+          <a:xfrm>
+            <a:off x="0" y="4960620"/>
+            <a:ext cx="9144000" cy="182880"/>
+          </a:xfrm>
+          <a:prstGeom prst="rect">
+            <a:avLst/>
+          </a:prstGeom>
+          <a:solidFill>
+            <a:srgbClr val="E74C3C"/>
+          </a:solidFill>
+          <a:ln>
+            <a:noFill/>
+          </a:ln>
+        </p:spPr>
+        <p:style>
+          <a:lnRef idx="1">
+            <a:schemeClr val="accent1"/>
+          </a:lnRef>
+          <a:fillRef idx="3">
+            <a:schemeClr val="accent1"/>
+          </a:fillRef>
+          <a:effectRef idx="2">
+            <a:schemeClr val="accent1"/>
+          </a:effectRef>
+          <a:fontRef idx="minor">
+            <a:schemeClr val="lt1"/>
+          </a:fontRef>
+        </p:style>
+        <p:txBody>
+          <a:bodyPr rtlCol="0" anchor="ctr"/>
+          <a:lstStyle/>
+          <a:p>
+            <a:pPr algn="ctr"/>
+          </a:p>
+        </p:txBody>
+      </p:sp>
+      <p:sp>
+        <p:nvSpPr>
+          <p:cNvPr id="6" name="Rectangle 5"/>
+          <p:cNvSpPr/>
+          <p:nvPr/>
+        </p:nvSpPr>
+        <p:spPr>
+          <a:xfrm>
+            <a:off x="6858000" y="0"/>
+            <a:ext cx="2286000" cy="1371600"/>
+          </a:xfrm>
+          <a:prstGeom prst="rect">
+            <a:avLst/>
+          </a:prstGeom>
+          <a:solidFill>
+            <a:srgbClr val="95A5A6"/>
+          </a:solidFill>
+          <a:ln>
+            <a:noFill/>
+          </a:ln>
+        </p:spPr>
+        <p:style>
+          <a:lnRef idx="1">
+            <a:schemeClr val="accent1"/>
+          </a:lnRef>
+          <a:fillRef idx="3">
+            <a:schemeClr val="accent1"/>
+          </a:fillRef>
+          <a:effectRef idx="2">
+            <a:schemeClr val="accent1"/>
+          </a:effectRef>
+          <a:fontRef idx="minor">
+            <a:schemeClr val="lt1"/>
+          </a:fontRef>
+        </p:style>
+        <p:txBody>
+          <a:bodyPr rtlCol="0" anchor="ctr"/>
+          <a:lstStyle/>
+          <a:p>
+            <a:pPr algn="ctr"/>
           </a:p>
         </p:txBody>
       </p:sp>
@@ -3156,6 +3301,22 @@
 <file path=ppt/slides/slide2.xml><?xml version="1.0" encoding="utf-8"?>
 <p:sld xmlns:a="http://schemas.openxmlformats.org/drawingml/2006/main" xmlns:p="http://schemas.openxmlformats.org/presentationml/2006/main" xmlns:r="http://schemas.openxmlformats.org/officeDocument/2006/relationships">
   <p:cSld>
+    <p:bg>
+      <p:bgPr>
+        <a:gradFill rotWithShape="1">
+          <a:gsLst>
+            <a:gs pos="0">
+              <a:srgbClr val="2C3E50"/>
+            </a:gs>
+            <a:gs pos="100000">
+              <a:srgbClr val="34495E"/>
+            </a:gs>
+          </a:gsLst>
+          <a:lin scaled="0" ang="16200000"/>
+        </a:gradFill>
+        <a:effectLst/>
+      </p:bgPr>
+    </p:bg>
     <p:spTree>
       <p:nvGrpSpPr>
         <p:cNvPr id="1" name=""/>
@@ -3179,9 +3340,9 @@
           <a:lstStyle/>
           <a:p>
             <a:pPr>
-              <a:defRPr sz="2800">
+              <a:defRPr sz="3200" b="1">
                 <a:solidFill>
-                  <a:srgbClr val="333333"/>
+                  <a:srgbClr val="FFFFFF"/>
                 </a:solidFill>
               </a:defRPr>
             </a:pPr>
@@ -3207,7 +3368,11 @@
           <a:lstStyle/>
           <a:p>
             <a:pPr>
-              <a:defRPr sz="1600"/>
+              <a:defRPr sz="1800">
+                <a:solidFill>
+                  <a:srgbClr val="ECF0F1"/>
+                </a:solidFill>
+              </a:defRPr>
             </a:pPr>
             <a:r>
               <a:t>研究背景与动机</a:t>
@@ -3215,11 +3380,113 @@
           </a:p>
           <a:p>
             <a:pPr>
-              <a:defRPr sz="1600"/>
+              <a:defRPr sz="1800">
+                <a:solidFill>
+                  <a:srgbClr val="ECF0F1"/>
+                </a:solidFill>
+              </a:defRPr>
             </a:pPr>
             <a:r>
               <a:t>研究方法与实验设计</a:t>
             </a:r>
+          </a:p>
+          <a:p>
+            <a:pPr>
+              <a:defRPr sz="1800">
+                <a:solidFill>
+                  <a:srgbClr val="ECF0F1"/>
+                </a:solidFill>
+              </a:defRPr>
+            </a:pPr>
+            <a:r>
+              <a:t>结果分析与讨论</a:t>
+            </a:r>
+          </a:p>
+        </p:txBody>
+      </p:sp>
+      <p:sp>
+        <p:nvSpPr>
+          <p:cNvPr id="4" name="Rectangle 3"/>
+          <p:cNvSpPr/>
+          <p:nvPr/>
+        </p:nvSpPr>
+        <p:spPr>
+          <a:xfrm>
+            <a:off x="0" y="0"/>
+            <a:ext cx="182880" cy="5143500"/>
+          </a:xfrm>
+          <a:prstGeom prst="rect">
+            <a:avLst/>
+          </a:prstGeom>
+          <a:solidFill>
+            <a:srgbClr val="E74C3C"/>
+          </a:solidFill>
+          <a:ln>
+            <a:noFill/>
+          </a:ln>
+        </p:spPr>
+        <p:style>
+          <a:lnRef idx="1">
+            <a:schemeClr val="accent1"/>
+          </a:lnRef>
+          <a:fillRef idx="3">
+            <a:schemeClr val="accent1"/>
+          </a:fillRef>
+          <a:effectRef idx="2">
+            <a:schemeClr val="accent1"/>
+          </a:effectRef>
+          <a:fontRef idx="minor">
+            <a:schemeClr val="lt1"/>
+          </a:fontRef>
+        </p:style>
+        <p:txBody>
+          <a:bodyPr rtlCol="0" anchor="ctr"/>
+          <a:lstStyle/>
+          <a:p>
+            <a:pPr algn="ctr"/>
+          </a:p>
+        </p:txBody>
+      </p:sp>
+      <p:sp>
+        <p:nvSpPr>
+          <p:cNvPr id="5" name="Rectangle 4"/>
+          <p:cNvSpPr/>
+          <p:nvPr/>
+        </p:nvSpPr>
+        <p:spPr>
+          <a:xfrm>
+            <a:off x="457200" y="1005840"/>
+            <a:ext cx="2743200" cy="45720"/>
+          </a:xfrm>
+          <a:prstGeom prst="rect">
+            <a:avLst/>
+          </a:prstGeom>
+          <a:solidFill>
+            <a:srgbClr val="E74C3C"/>
+          </a:solidFill>
+          <a:ln>
+            <a:noFill/>
+          </a:ln>
+        </p:spPr>
+        <p:style>
+          <a:lnRef idx="1">
+            <a:schemeClr val="accent1"/>
+          </a:lnRef>
+          <a:fillRef idx="3">
+            <a:schemeClr val="accent1"/>
+          </a:fillRef>
+          <a:effectRef idx="2">
+            <a:schemeClr val="accent1"/>
+          </a:effectRef>
+          <a:fontRef idx="minor">
+            <a:schemeClr val="lt1"/>
+          </a:fontRef>
+        </p:style>
+        <p:txBody>
+          <a:bodyPr rtlCol="0" anchor="ctr"/>
+          <a:lstStyle/>
+          <a:p>
+            <a:pPr algn="ctr"/>
           </a:p>
         </p:txBody>
       </p:sp>

</xml_diff>

<commit_message>
feat: add catalog slide and style-specific PPT generators for business and academic templates
</commit_message>
<xml_diff>
--- a/config/templates/academic_template.pptx
+++ b/config/templates/academic_template.pptx
@@ -7,8 +7,10 @@
   <p:sldIdLst>
     <p:sldId id="256" r:id="rId7"/>
     <p:sldId id="257" r:id="rId8"/>
+    <p:sldId id="258" r:id="rId9"/>
+    <p:sldId id="259" r:id="rId10"/>
   </p:sldIdLst>
-  <p:sldSz cx="9144000" cy="5143500" type="screen4x3"/>
+  <p:sldSz cx="12188952" cy="6858000" type="screen4x3"/>
   <p:notesSz cx="6858000" cy="9144000"/>
   <p:defaultTextStyle>
     <a:defPPr>
@@ -3087,10 +3089,10 @@
         <a:gradFill rotWithShape="1">
           <a:gsLst>
             <a:gs pos="0">
-              <a:srgbClr val="2C3E50"/>
+              <a:srgbClr val="006644"/>
             </a:gs>
             <a:gs pos="100000">
-              <a:srgbClr val="34495E"/>
+              <a:srgbClr val="4CAF50"/>
             </a:gs>
           </a:gsLst>
           <a:lin scaled="0" ang="16200000"/>
@@ -3107,76 +3109,20 @@
       <p:grpSpPr/>
       <p:sp>
         <p:nvSpPr>
-          <p:cNvPr id="2" name="Title 1"/>
-          <p:cNvSpPr>
-            <a:spLocks noGrp="1"/>
-          </p:cNvSpPr>
-          <p:nvPr>
-            <p:ph type="ctrTitle"/>
-          </p:nvPr>
-        </p:nvSpPr>
-        <p:spPr/>
-        <p:txBody>
-          <a:bodyPr/>
-          <a:lstStyle/>
-          <a:p>
-            <a:pPr>
-              <a:defRPr sz="4800" b="1">
-                <a:solidFill>
-                  <a:srgbClr val="FFFFFF"/>
-                </a:solidFill>
-              </a:defRPr>
-            </a:pPr>
-            <a:r>
-              <a:t>学术报告风格</a:t>
-            </a:r>
-          </a:p>
-        </p:txBody>
-      </p:sp>
-      <p:sp>
-        <p:nvSpPr>
-          <p:cNvPr id="3" name="Subtitle 2"/>
-          <p:cNvSpPr>
-            <a:spLocks noGrp="1"/>
-          </p:cNvSpPr>
-          <p:nvPr>
-            <p:ph type="subTitle" idx="1"/>
-          </p:nvPr>
-        </p:nvSpPr>
-        <p:spPr/>
-        <p:txBody>
-          <a:bodyPr/>
-          <a:lstStyle/>
-          <a:p>
-            <a:pPr>
-              <a:defRPr sz="2400">
-                <a:solidFill>
-                  <a:srgbClr val="ECF0F1"/>
-                </a:solidFill>
-              </a:defRPr>
-            </a:pPr>
-            <a:r>
-              <a:t>Research · Innovation · Excellence</a:t>
-            </a:r>
-          </a:p>
-        </p:txBody>
-      </p:sp>
-      <p:sp>
-        <p:nvSpPr>
-          <p:cNvPr id="4" name="Rectangle 3"/>
+          <p:cNvPr id="2" name="Rectangle 1"/>
           <p:cNvSpPr/>
           <p:nvPr/>
         </p:nvSpPr>
         <p:spPr>
           <a:xfrm>
             <a:off x="0" y="0"/>
-            <a:ext cx="182880" cy="5143500"/>
+            <a:ext cx="12188952" cy="274320"/>
           </a:xfrm>
           <a:prstGeom prst="rect">
             <a:avLst/>
           </a:prstGeom>
           <a:solidFill>
-            <a:srgbClr val="E74C3C"/>
+            <a:srgbClr val="FFC107"/>
           </a:solidFill>
           <a:ln>
             <a:noFill/>
@@ -3206,20 +3152,199 @@
       </p:sp>
       <p:sp>
         <p:nvSpPr>
-          <p:cNvPr id="5" name="Rectangle 4"/>
+          <p:cNvPr id="3" name="TextBox 2"/>
+          <p:cNvSpPr txBox="1"/>
+          <p:nvPr/>
+        </p:nvSpPr>
+        <p:spPr>
+          <a:xfrm>
+            <a:off x="1371600" y="2560320"/>
+            <a:ext cx="9144000" cy="1097280"/>
+          </a:xfrm>
+          <a:prstGeom prst="rect">
+            <a:avLst/>
+          </a:prstGeom>
+          <a:noFill/>
+        </p:spPr>
+        <p:txBody>
+          <a:bodyPr wrap="none">
+            <a:spAutoFit/>
+          </a:bodyPr>
+          <a:lstStyle/>
+          <a:p>
+            <a:pPr algn="ctr">
+              <a:defRPr sz="5400" b="1">
+                <a:solidFill>
+                  <a:srgbClr val="FFFFFF"/>
+                </a:solidFill>
+              </a:defRPr>
+            </a:pPr>
+            <a:r>
+              <a:t>学术研究报告标题</a:t>
+            </a:r>
+          </a:p>
+        </p:txBody>
+      </p:sp>
+      <p:sp>
+        <p:nvSpPr>
+          <p:cNvPr id="4" name="TextBox 3"/>
+          <p:cNvSpPr txBox="1"/>
+          <p:nvPr/>
+        </p:nvSpPr>
+        <p:spPr>
+          <a:xfrm>
+            <a:off x="1828800" y="3840480"/>
+            <a:ext cx="8531352" cy="457200"/>
+          </a:xfrm>
+          <a:prstGeom prst="rect">
+            <a:avLst/>
+          </a:prstGeom>
+          <a:noFill/>
+        </p:spPr>
+        <p:txBody>
+          <a:bodyPr wrap="none">
+            <a:spAutoFit/>
+          </a:bodyPr>
+          <a:lstStyle/>
+          <a:p>
+            <a:pPr algn="ctr">
+              <a:defRPr sz="2000">
+                <a:solidFill>
+                  <a:srgbClr val="FFFFFF"/>
+                </a:solidFill>
+              </a:defRPr>
+            </a:pPr>
+            <a:r>
+              <a:t>副标题或研究方向</a:t>
+            </a:r>
+          </a:p>
+        </p:txBody>
+      </p:sp>
+      <p:sp>
+        <p:nvSpPr>
+          <p:cNvPr id="5" name="TextBox 4"/>
+          <p:cNvSpPr txBox="1"/>
+          <p:nvPr/>
+        </p:nvSpPr>
+        <p:spPr>
+          <a:xfrm>
+            <a:off x="1371600" y="5669280"/>
+            <a:ext cx="3657600" cy="731520"/>
+          </a:xfrm>
+          <a:prstGeom prst="rect">
+            <a:avLst/>
+          </a:prstGeom>
+          <a:noFill/>
+        </p:spPr>
+        <p:txBody>
+          <a:bodyPr wrap="none">
+            <a:spAutoFit/>
+          </a:bodyPr>
+          <a:lstStyle/>
+          <a:p>
+            <a:pPr>
+              <a:defRPr sz="1600">
+                <a:solidFill>
+                  <a:srgbClr val="FFFFFF"/>
+                </a:solidFill>
+              </a:defRPr>
+            </a:pPr>
+            <a:r>
+              <a:t>作者: XXX</a:t>
+            </a:r>
+          </a:p>
+          <a:p>
+            <a:r>
+              <a:t>单位: XXX大学</a:t>
+            </a:r>
+          </a:p>
+        </p:txBody>
+      </p:sp>
+      <p:sp>
+        <p:nvSpPr>
+          <p:cNvPr id="6" name="TextBox 5"/>
+          <p:cNvSpPr txBox="1"/>
+          <p:nvPr/>
+        </p:nvSpPr>
+        <p:spPr>
+          <a:xfrm>
+            <a:off x="7315200" y="5943600"/>
+            <a:ext cx="3200400" cy="457200"/>
+          </a:xfrm>
+          <a:prstGeom prst="rect">
+            <a:avLst/>
+          </a:prstGeom>
+          <a:noFill/>
+        </p:spPr>
+        <p:txBody>
+          <a:bodyPr wrap="none">
+            <a:spAutoFit/>
+          </a:bodyPr>
+          <a:lstStyle/>
+          <a:p>
+            <a:pPr algn="r">
+              <a:defRPr sz="1600">
+                <a:solidFill>
+                  <a:srgbClr val="FFFFFF"/>
+                </a:solidFill>
+              </a:defRPr>
+            </a:pPr>
+            <a:r>
+              <a:t>日期: 2025/01/01</a:t>
+            </a:r>
+          </a:p>
+        </p:txBody>
+      </p:sp>
+    </p:spTree>
+  </p:cSld>
+  <p:clrMapOvr>
+    <a:masterClrMapping/>
+  </p:clrMapOvr>
+</p:sld>
+</file>
+
+<file path=ppt/slides/slide2.xml><?xml version="1.0" encoding="utf-8"?>
+<p:sld xmlns:a="http://schemas.openxmlformats.org/drawingml/2006/main" xmlns:p="http://schemas.openxmlformats.org/presentationml/2006/main" xmlns:r="http://schemas.openxmlformats.org/officeDocument/2006/relationships">
+  <p:cSld>
+    <p:bg>
+      <p:bgPr>
+        <a:gradFill rotWithShape="1">
+          <a:gsLst>
+            <a:gs pos="0">
+              <a:srgbClr val="006644"/>
+            </a:gs>
+            <a:gs pos="100000">
+              <a:srgbClr val="4CAF50"/>
+            </a:gs>
+          </a:gsLst>
+          <a:lin scaled="0" ang="16200000"/>
+        </a:gradFill>
+        <a:effectLst/>
+      </p:bgPr>
+    </p:bg>
+    <p:spTree>
+      <p:nvGrpSpPr>
+        <p:cNvPr id="1" name=""/>
+        <p:cNvGrpSpPr/>
+        <p:nvPr/>
+      </p:nvGrpSpPr>
+      <p:grpSpPr/>
+      <p:sp>
+        <p:nvSpPr>
+          <p:cNvPr id="2" name="Rectangle 1"/>
           <p:cNvSpPr/>
           <p:nvPr/>
         </p:nvSpPr>
         <p:spPr>
           <a:xfrm>
-            <a:off x="0" y="4960620"/>
-            <a:ext cx="9144000" cy="182880"/>
+            <a:off x="0" y="0"/>
+            <a:ext cx="12188952" cy="274320"/>
           </a:xfrm>
           <a:prstGeom prst="rect">
             <a:avLst/>
           </a:prstGeom>
           <a:solidFill>
-            <a:srgbClr val="E74C3C"/>
+            <a:srgbClr val="FFC107"/>
           </a:solidFill>
           <a:ln>
             <a:noFill/>
@@ -3249,20 +3374,92 @@
       </p:sp>
       <p:sp>
         <p:nvSpPr>
-          <p:cNvPr id="6" name="Rectangle 5"/>
-          <p:cNvSpPr/>
+          <p:cNvPr id="3" name="TextBox 2"/>
+          <p:cNvSpPr txBox="1"/>
           <p:nvPr/>
         </p:nvSpPr>
         <p:spPr>
           <a:xfrm>
-            <a:off x="6858000" y="0"/>
-            <a:ext cx="2286000" cy="1371600"/>
+            <a:off x="914400" y="731520"/>
+            <a:ext cx="2743200" cy="731520"/>
           </a:xfrm>
           <a:prstGeom prst="rect">
             <a:avLst/>
           </a:prstGeom>
+          <a:noFill/>
+        </p:spPr>
+        <p:txBody>
+          <a:bodyPr wrap="none">
+            <a:spAutoFit/>
+          </a:bodyPr>
+          <a:lstStyle/>
+          <a:p>
+            <a:pPr>
+              <a:defRPr sz="4800" b="1">
+                <a:solidFill>
+                  <a:srgbClr val="FFFFFF"/>
+                </a:solidFill>
+              </a:defRPr>
+            </a:pPr>
+            <a:r>
+              <a:t>目录</a:t>
+            </a:r>
+          </a:p>
+        </p:txBody>
+      </p:sp>
+      <p:sp>
+        <p:nvSpPr>
+          <p:cNvPr id="4" name="TextBox 3"/>
+          <p:cNvSpPr txBox="1"/>
+          <p:nvPr/>
+        </p:nvSpPr>
+        <p:spPr>
+          <a:xfrm>
+            <a:off x="3657600" y="914400"/>
+            <a:ext cx="2743200" cy="457200"/>
+          </a:xfrm>
+          <a:prstGeom prst="rect">
+            <a:avLst/>
+          </a:prstGeom>
+          <a:noFill/>
+        </p:spPr>
+        <p:txBody>
+          <a:bodyPr wrap="none">
+            <a:spAutoFit/>
+          </a:bodyPr>
+          <a:lstStyle/>
+          <a:p>
+            <a:pPr>
+              <a:defRPr sz="2400">
+                <a:solidFill>
+                  <a:srgbClr val="969696"/>
+                </a:solidFill>
+              </a:defRPr>
+            </a:pPr>
+            <a:r>
+              <a:t>CONTENTS</a:t>
+            </a:r>
+          </a:p>
+        </p:txBody>
+      </p:sp>
+      <p:sp>
+        <p:nvSpPr>
+          <p:cNvPr id="5" name="Rounded Rectangle 4"/>
+          <p:cNvSpPr/>
+          <p:nvPr/>
+        </p:nvSpPr>
+        <p:spPr>
+          <a:xfrm>
+            <a:off x="1371600" y="2011680"/>
+            <a:ext cx="9144000" cy="548640"/>
+          </a:xfrm>
+          <a:prstGeom prst="roundRect">
+            <a:avLst/>
+          </a:prstGeom>
           <a:solidFill>
-            <a:srgbClr val="95A5A6"/>
+            <a:srgbClr val="FFFFFF">
+              <a:lumMod val="90000"/>
+            </a:srgbClr>
           </a:solidFill>
           <a:ln>
             <a:noFill/>
@@ -3283,143 +3480,40 @@
           </a:fontRef>
         </p:style>
         <p:txBody>
-          <a:bodyPr rtlCol="0" anchor="ctr"/>
-          <a:lstStyle/>
-          <a:p>
-            <a:pPr algn="ctr"/>
-          </a:p>
-        </p:txBody>
-      </p:sp>
-    </p:spTree>
-  </p:cSld>
-  <p:clrMapOvr>
-    <a:masterClrMapping/>
-  </p:clrMapOvr>
-</p:sld>
-</file>
-
-<file path=ppt/slides/slide2.xml><?xml version="1.0" encoding="utf-8"?>
-<p:sld xmlns:a="http://schemas.openxmlformats.org/drawingml/2006/main" xmlns:p="http://schemas.openxmlformats.org/presentationml/2006/main" xmlns:r="http://schemas.openxmlformats.org/officeDocument/2006/relationships">
-  <p:cSld>
-    <p:bg>
-      <p:bgPr>
-        <a:gradFill rotWithShape="1">
-          <a:gsLst>
-            <a:gs pos="0">
-              <a:srgbClr val="2C3E50"/>
-            </a:gs>
-            <a:gs pos="100000">
-              <a:srgbClr val="34495E"/>
-            </a:gs>
-          </a:gsLst>
-          <a:lin scaled="0" ang="16200000"/>
-        </a:gradFill>
-        <a:effectLst/>
-      </p:bgPr>
-    </p:bg>
-    <p:spTree>
-      <p:nvGrpSpPr>
-        <p:cNvPr id="1" name=""/>
-        <p:cNvGrpSpPr/>
-        <p:nvPr/>
-      </p:nvGrpSpPr>
-      <p:grpSpPr/>
-      <p:sp>
-        <p:nvSpPr>
-          <p:cNvPr id="2" name="Title 1"/>
-          <p:cNvSpPr>
-            <a:spLocks noGrp="1"/>
-          </p:cNvSpPr>
-          <p:nvPr>
-            <p:ph type="title"/>
-          </p:nvPr>
-        </p:nvSpPr>
-        <p:spPr/>
-        <p:txBody>
-          <a:bodyPr/>
+          <a:bodyPr rtlCol="0" anchor="ctr" lIns="274320"/>
           <a:lstStyle/>
           <a:p>
             <a:pPr>
-              <a:defRPr sz="3200" b="1">
+              <a:defRPr sz="2000">
                 <a:solidFill>
-                  <a:srgbClr val="FFFFFF"/>
+                  <a:srgbClr val="323232"/>
                 </a:solidFill>
               </a:defRPr>
             </a:pPr>
             <a:r>
-              <a:t>研究内容</a:t>
-            </a:r>
-          </a:p>
-        </p:txBody>
-      </p:sp>
-      <p:sp>
-        <p:nvSpPr>
-          <p:cNvPr id="3" name="Content Placeholder 2"/>
-          <p:cNvSpPr>
-            <a:spLocks noGrp="1"/>
-          </p:cNvSpPr>
-          <p:nvPr>
-            <p:ph idx="1"/>
-          </p:nvPr>
-        </p:nvSpPr>
-        <p:spPr/>
-        <p:txBody>
-          <a:bodyPr/>
-          <a:lstStyle/>
-          <a:p>
-            <a:pPr>
-              <a:defRPr sz="1800">
-                <a:solidFill>
-                  <a:srgbClr val="ECF0F1"/>
-                </a:solidFill>
-              </a:defRPr>
-            </a:pPr>
-            <a:r>
-              <a:t>研究背景与动机</a:t>
-            </a:r>
-          </a:p>
-          <a:p>
-            <a:pPr>
-              <a:defRPr sz="1800">
-                <a:solidFill>
-                  <a:srgbClr val="ECF0F1"/>
-                </a:solidFill>
-              </a:defRPr>
-            </a:pPr>
-            <a:r>
-              <a:t>研究方法与实验设计</a:t>
-            </a:r>
-          </a:p>
-          <a:p>
-            <a:pPr>
-              <a:defRPr sz="1800">
-                <a:solidFill>
-                  <a:srgbClr val="ECF0F1"/>
-                </a:solidFill>
-              </a:defRPr>
-            </a:pPr>
-            <a:r>
-              <a:t>结果分析与讨论</a:t>
-            </a:r>
-          </a:p>
-        </p:txBody>
-      </p:sp>
-      <p:sp>
-        <p:nvSpPr>
-          <p:cNvPr id="4" name="Rectangle 3"/>
+              <a:t>01  研究背景与意义</a:t>
+            </a:r>
+          </a:p>
+        </p:txBody>
+      </p:sp>
+      <p:sp>
+        <p:nvSpPr>
+          <p:cNvPr id="6" name="Rounded Rectangle 5"/>
           <p:cNvSpPr/>
           <p:nvPr/>
         </p:nvSpPr>
         <p:spPr>
           <a:xfrm>
-            <a:off x="0" y="0"/>
-            <a:ext cx="182880" cy="5143500"/>
+            <a:off x="1371600" y="2743200"/>
+            <a:ext cx="9144000" cy="548640"/>
           </a:xfrm>
-          <a:prstGeom prst="rect">
+          <a:prstGeom prst="roundRect">
             <a:avLst/>
           </a:prstGeom>
           <a:solidFill>
-            <a:srgbClr val="E74C3C"/>
+            <a:srgbClr val="FFFFFF">
+              <a:lumMod val="90000"/>
+            </a:srgbClr>
           </a:solidFill>
           <a:ln>
             <a:noFill/>
@@ -3440,29 +3534,40 @@
           </a:fontRef>
         </p:style>
         <p:txBody>
-          <a:bodyPr rtlCol="0" anchor="ctr"/>
-          <a:lstStyle/>
-          <a:p>
-            <a:pPr algn="ctr"/>
-          </a:p>
-        </p:txBody>
-      </p:sp>
-      <p:sp>
-        <p:nvSpPr>
-          <p:cNvPr id="5" name="Rectangle 4"/>
+          <a:bodyPr rtlCol="0" anchor="ctr" lIns="274320"/>
+          <a:lstStyle/>
+          <a:p>
+            <a:pPr>
+              <a:defRPr sz="2000">
+                <a:solidFill>
+                  <a:srgbClr val="323232"/>
+                </a:solidFill>
+              </a:defRPr>
+            </a:pPr>
+            <a:r>
+              <a:t>02  文献综述</a:t>
+            </a:r>
+          </a:p>
+        </p:txBody>
+      </p:sp>
+      <p:sp>
+        <p:nvSpPr>
+          <p:cNvPr id="7" name="Rounded Rectangle 6"/>
           <p:cNvSpPr/>
           <p:nvPr/>
         </p:nvSpPr>
         <p:spPr>
           <a:xfrm>
-            <a:off x="457200" y="1005840"/>
-            <a:ext cx="2743200" cy="45720"/>
+            <a:off x="1371600" y="3474720"/>
+            <a:ext cx="9144000" cy="548640"/>
           </a:xfrm>
-          <a:prstGeom prst="rect">
+          <a:prstGeom prst="roundRect">
             <a:avLst/>
           </a:prstGeom>
           <a:solidFill>
-            <a:srgbClr val="E74C3C"/>
+            <a:srgbClr val="FFFFFF">
+              <a:lumMod val="90000"/>
+            </a:srgbClr>
           </a:solidFill>
           <a:ln>
             <a:noFill/>
@@ -3483,10 +3588,465 @@
           </a:fontRef>
         </p:style>
         <p:txBody>
+          <a:bodyPr rtlCol="0" anchor="ctr" lIns="274320"/>
+          <a:lstStyle/>
+          <a:p>
+            <a:pPr>
+              <a:defRPr sz="2000">
+                <a:solidFill>
+                  <a:srgbClr val="323232"/>
+                </a:solidFill>
+              </a:defRPr>
+            </a:pPr>
+            <a:r>
+              <a:t>03  研究方法</a:t>
+            </a:r>
+          </a:p>
+        </p:txBody>
+      </p:sp>
+      <p:sp>
+        <p:nvSpPr>
+          <p:cNvPr id="8" name="Rounded Rectangle 7"/>
+          <p:cNvSpPr/>
+          <p:nvPr/>
+        </p:nvSpPr>
+        <p:spPr>
+          <a:xfrm>
+            <a:off x="1371600" y="4206240"/>
+            <a:ext cx="9144000" cy="548640"/>
+          </a:xfrm>
+          <a:prstGeom prst="roundRect">
+            <a:avLst/>
+          </a:prstGeom>
+          <a:solidFill>
+            <a:srgbClr val="FFFFFF">
+              <a:lumMod val="90000"/>
+            </a:srgbClr>
+          </a:solidFill>
+          <a:ln>
+            <a:noFill/>
+          </a:ln>
+        </p:spPr>
+        <p:style>
+          <a:lnRef idx="1">
+            <a:schemeClr val="accent1"/>
+          </a:lnRef>
+          <a:fillRef idx="3">
+            <a:schemeClr val="accent1"/>
+          </a:fillRef>
+          <a:effectRef idx="2">
+            <a:schemeClr val="accent1"/>
+          </a:effectRef>
+          <a:fontRef idx="minor">
+            <a:schemeClr val="lt1"/>
+          </a:fontRef>
+        </p:style>
+        <p:txBody>
+          <a:bodyPr rtlCol="0" anchor="ctr" lIns="274320"/>
+          <a:lstStyle/>
+          <a:p>
+            <a:pPr>
+              <a:defRPr sz="2000">
+                <a:solidFill>
+                  <a:srgbClr val="323232"/>
+                </a:solidFill>
+              </a:defRPr>
+            </a:pPr>
+            <a:r>
+              <a:t>04  实验结果</a:t>
+            </a:r>
+          </a:p>
+        </p:txBody>
+      </p:sp>
+      <p:sp>
+        <p:nvSpPr>
+          <p:cNvPr id="9" name="Rounded Rectangle 8"/>
+          <p:cNvSpPr/>
+          <p:nvPr/>
+        </p:nvSpPr>
+        <p:spPr>
+          <a:xfrm>
+            <a:off x="1371600" y="4937760"/>
+            <a:ext cx="9144000" cy="548640"/>
+          </a:xfrm>
+          <a:prstGeom prst="roundRect">
+            <a:avLst/>
+          </a:prstGeom>
+          <a:solidFill>
+            <a:srgbClr val="FFFFFF">
+              <a:lumMod val="90000"/>
+            </a:srgbClr>
+          </a:solidFill>
+          <a:ln>
+            <a:noFill/>
+          </a:ln>
+        </p:spPr>
+        <p:style>
+          <a:lnRef idx="1">
+            <a:schemeClr val="accent1"/>
+          </a:lnRef>
+          <a:fillRef idx="3">
+            <a:schemeClr val="accent1"/>
+          </a:fillRef>
+          <a:effectRef idx="2">
+            <a:schemeClr val="accent1"/>
+          </a:effectRef>
+          <a:fontRef idx="minor">
+            <a:schemeClr val="lt1"/>
+          </a:fontRef>
+        </p:style>
+        <p:txBody>
+          <a:bodyPr rtlCol="0" anchor="ctr" lIns="274320"/>
+          <a:lstStyle/>
+          <a:p>
+            <a:pPr>
+              <a:defRPr sz="2000">
+                <a:solidFill>
+                  <a:srgbClr val="323232"/>
+                </a:solidFill>
+              </a:defRPr>
+            </a:pPr>
+            <a:r>
+              <a:t>05  结论与展望</a:t>
+            </a:r>
+          </a:p>
+        </p:txBody>
+      </p:sp>
+    </p:spTree>
+  </p:cSld>
+  <p:clrMapOvr>
+    <a:masterClrMapping/>
+  </p:clrMapOvr>
+</p:sld>
+</file>
+
+<file path=ppt/slides/slide3.xml><?xml version="1.0" encoding="utf-8"?>
+<p:sld xmlns:a="http://schemas.openxmlformats.org/drawingml/2006/main" xmlns:p="http://schemas.openxmlformats.org/presentationml/2006/main" xmlns:r="http://schemas.openxmlformats.org/officeDocument/2006/relationships">
+  <p:cSld>
+    <p:bg>
+      <p:bgPr>
+        <a:gradFill rotWithShape="1">
+          <a:gsLst>
+            <a:gs pos="0">
+              <a:srgbClr val="006644"/>
+            </a:gs>
+            <a:gs pos="100000">
+              <a:srgbClr val="4CAF50"/>
+            </a:gs>
+          </a:gsLst>
+          <a:lin scaled="0" ang="16200000"/>
+        </a:gradFill>
+        <a:effectLst/>
+      </p:bgPr>
+    </p:bg>
+    <p:spTree>
+      <p:nvGrpSpPr>
+        <p:cNvPr id="1" name=""/>
+        <p:cNvGrpSpPr/>
+        <p:nvPr/>
+      </p:nvGrpSpPr>
+      <p:grpSpPr/>
+      <p:sp>
+        <p:nvSpPr>
+          <p:cNvPr id="2" name="Rectangle 1"/>
+          <p:cNvSpPr/>
+          <p:nvPr/>
+        </p:nvSpPr>
+        <p:spPr>
+          <a:xfrm>
+            <a:off x="0" y="0"/>
+            <a:ext cx="12188952" cy="274320"/>
+          </a:xfrm>
+          <a:prstGeom prst="rect">
+            <a:avLst/>
+          </a:prstGeom>
+          <a:solidFill>
+            <a:srgbClr val="FFC107"/>
+          </a:solidFill>
+          <a:ln>
+            <a:noFill/>
+          </a:ln>
+        </p:spPr>
+        <p:style>
+          <a:lnRef idx="1">
+            <a:schemeClr val="accent1"/>
+          </a:lnRef>
+          <a:fillRef idx="3">
+            <a:schemeClr val="accent1"/>
+          </a:fillRef>
+          <a:effectRef idx="2">
+            <a:schemeClr val="accent1"/>
+          </a:effectRef>
+          <a:fontRef idx="minor">
+            <a:schemeClr val="lt1"/>
+          </a:fontRef>
+        </p:style>
+        <p:txBody>
           <a:bodyPr rtlCol="0" anchor="ctr"/>
           <a:lstStyle/>
           <a:p>
             <a:pPr algn="ctr"/>
+          </a:p>
+        </p:txBody>
+      </p:sp>
+      <p:sp>
+        <p:nvSpPr>
+          <p:cNvPr id="3" name="Rectangle 2"/>
+          <p:cNvSpPr/>
+          <p:nvPr/>
+        </p:nvSpPr>
+        <p:spPr>
+          <a:xfrm>
+            <a:off x="0" y="274320"/>
+            <a:ext cx="12188952" cy="822960"/>
+          </a:xfrm>
+          <a:prstGeom prst="rect">
+            <a:avLst/>
+          </a:prstGeom>
+          <a:solidFill>
+            <a:srgbClr val="FFFFFF"/>
+          </a:solidFill>
+          <a:ln>
+            <a:noFill/>
+          </a:ln>
+        </p:spPr>
+        <p:style>
+          <a:lnRef idx="1">
+            <a:schemeClr val="accent1"/>
+          </a:lnRef>
+          <a:fillRef idx="3">
+            <a:schemeClr val="accent1"/>
+          </a:fillRef>
+          <a:effectRef idx="2">
+            <a:schemeClr val="accent1"/>
+          </a:effectRef>
+          <a:fontRef idx="minor">
+            <a:schemeClr val="lt1"/>
+          </a:fontRef>
+        </p:style>
+        <p:txBody>
+          <a:bodyPr rtlCol="0" anchor="ctr" lIns="457200"/>
+          <a:lstStyle/>
+          <a:p>
+            <a:pPr>
+              <a:defRPr sz="3200" b="1">
+                <a:solidFill>
+                  <a:srgbClr val="006644"/>
+                </a:solidFill>
+              </a:defRPr>
+            </a:pPr>
+            <a:r>
+              <a:t>内容页标题</a:t>
+            </a:r>
+          </a:p>
+        </p:txBody>
+      </p:sp>
+      <p:sp>
+        <p:nvSpPr>
+          <p:cNvPr id="4" name="Rounded Rectangle 3"/>
+          <p:cNvSpPr/>
+          <p:nvPr/>
+        </p:nvSpPr>
+        <p:spPr>
+          <a:xfrm>
+            <a:off x="731520" y="1645920"/>
+            <a:ext cx="10725912" cy="4572000"/>
+          </a:xfrm>
+          <a:prstGeom prst="roundRect">
+            <a:avLst/>
+          </a:prstGeom>
+          <a:solidFill>
+            <a:srgbClr val="FFFFFF"/>
+          </a:solidFill>
+          <a:ln>
+            <a:noFill/>
+          </a:ln>
+        </p:spPr>
+        <p:style>
+          <a:lnRef idx="1">
+            <a:schemeClr val="accent1"/>
+          </a:lnRef>
+          <a:fillRef idx="3">
+            <a:schemeClr val="accent1"/>
+          </a:fillRef>
+          <a:effectRef idx="2">
+            <a:schemeClr val="accent1"/>
+          </a:effectRef>
+          <a:fontRef idx="minor">
+            <a:schemeClr val="lt1"/>
+          </a:fontRef>
+        </p:style>
+        <p:txBody>
+          <a:bodyPr rtlCol="0" anchor="ctr" lIns="457200" tIns="274320"/>
+          <a:lstStyle/>
+          <a:p>
+            <a:pPr>
+              <a:defRPr sz="2200">
+                <a:solidFill>
+                  <a:srgbClr val="323232"/>
+                </a:solidFill>
+              </a:defRPr>
+            </a:pPr>
+            <a:r>
+              <a:t>• 研究要点1</a:t>
+            </a:r>
+          </a:p>
+          <a:p>
+            <a:r>
+              <a:t>• 研究要点2</a:t>
+            </a:r>
+          </a:p>
+          <a:p>
+            <a:r>
+              <a:t>• 研究要点3</a:t>
+            </a:r>
+          </a:p>
+        </p:txBody>
+      </p:sp>
+    </p:spTree>
+  </p:cSld>
+  <p:clrMapOvr>
+    <a:masterClrMapping/>
+  </p:clrMapOvr>
+</p:sld>
+</file>
+
+<file path=ppt/slides/slide4.xml><?xml version="1.0" encoding="utf-8"?>
+<p:sld xmlns:a="http://schemas.openxmlformats.org/drawingml/2006/main" xmlns:p="http://schemas.openxmlformats.org/presentationml/2006/main" xmlns:r="http://schemas.openxmlformats.org/officeDocument/2006/relationships">
+  <p:cSld>
+    <p:bg>
+      <p:bgPr>
+        <a:gradFill rotWithShape="1">
+          <a:gsLst>
+            <a:gs pos="0">
+              <a:srgbClr val="006644"/>
+            </a:gs>
+            <a:gs pos="100000">
+              <a:srgbClr val="4CAF50"/>
+            </a:gs>
+          </a:gsLst>
+          <a:lin scaled="0" ang="16200000"/>
+        </a:gradFill>
+        <a:effectLst/>
+      </p:bgPr>
+    </p:bg>
+    <p:spTree>
+      <p:nvGrpSpPr>
+        <p:cNvPr id="1" name=""/>
+        <p:cNvGrpSpPr/>
+        <p:nvPr/>
+      </p:nvGrpSpPr>
+      <p:grpSpPr/>
+      <p:sp>
+        <p:nvSpPr>
+          <p:cNvPr id="2" name="Rectangle 1"/>
+          <p:cNvSpPr/>
+          <p:nvPr/>
+        </p:nvSpPr>
+        <p:spPr>
+          <a:xfrm>
+            <a:off x="0" y="0"/>
+            <a:ext cx="12188952" cy="274320"/>
+          </a:xfrm>
+          <a:prstGeom prst="rect">
+            <a:avLst/>
+          </a:prstGeom>
+          <a:solidFill>
+            <a:srgbClr val="FFC107"/>
+          </a:solidFill>
+          <a:ln>
+            <a:noFill/>
+          </a:ln>
+        </p:spPr>
+        <p:style>
+          <a:lnRef idx="1">
+            <a:schemeClr val="accent1"/>
+          </a:lnRef>
+          <a:fillRef idx="3">
+            <a:schemeClr val="accent1"/>
+          </a:fillRef>
+          <a:effectRef idx="2">
+            <a:schemeClr val="accent1"/>
+          </a:effectRef>
+          <a:fontRef idx="minor">
+            <a:schemeClr val="lt1"/>
+          </a:fontRef>
+        </p:style>
+        <p:txBody>
+          <a:bodyPr rtlCol="0" anchor="ctr"/>
+          <a:lstStyle/>
+          <a:p>
+            <a:pPr algn="ctr"/>
+          </a:p>
+        </p:txBody>
+      </p:sp>
+      <p:sp>
+        <p:nvSpPr>
+          <p:cNvPr id="3" name="TextBox 2"/>
+          <p:cNvSpPr txBox="1"/>
+          <p:nvPr/>
+        </p:nvSpPr>
+        <p:spPr>
+          <a:xfrm>
+            <a:off x="2743200" y="2286000"/>
+            <a:ext cx="6702552" cy="1371600"/>
+          </a:xfrm>
+          <a:prstGeom prst="rect">
+            <a:avLst/>
+          </a:prstGeom>
+          <a:noFill/>
+        </p:spPr>
+        <p:txBody>
+          <a:bodyPr wrap="none">
+            <a:spAutoFit/>
+          </a:bodyPr>
+          <a:lstStyle/>
+          <a:p>
+            <a:pPr algn="ctr">
+              <a:defRPr sz="10000" b="1">
+                <a:solidFill>
+                  <a:srgbClr val="FFC107"/>
+                </a:solidFill>
+              </a:defRPr>
+            </a:pPr>
+            <a:r>
+              <a:t>01</a:t>
+            </a:r>
+          </a:p>
+        </p:txBody>
+      </p:sp>
+      <p:sp>
+        <p:nvSpPr>
+          <p:cNvPr id="4" name="TextBox 3"/>
+          <p:cNvSpPr txBox="1"/>
+          <p:nvPr/>
+        </p:nvSpPr>
+        <p:spPr>
+          <a:xfrm>
+            <a:off x="2743200" y="3840480"/>
+            <a:ext cx="6702552" cy="731520"/>
+          </a:xfrm>
+          <a:prstGeom prst="rect">
+            <a:avLst/>
+          </a:prstGeom>
+          <a:noFill/>
+        </p:spPr>
+        <p:txBody>
+          <a:bodyPr wrap="none">
+            <a:spAutoFit/>
+          </a:bodyPr>
+          <a:lstStyle/>
+          <a:p>
+            <a:pPr algn="ctr">
+              <a:defRPr sz="4000" b="1">
+                <a:solidFill>
+                  <a:srgbClr val="FFFFFF"/>
+                </a:solidFill>
+              </a:defRPr>
+            </a:pPr>
+            <a:r>
+              <a:t>章节标题</a:t>
+            </a:r>
           </a:p>
         </p:txBody>
       </p:sp>

</xml_diff>